<commit_message>
fix: Remove Lovable references from all docs; add tenant.admin test account
- Remove 'Lovable' branding from client-facing docs (Onboarding Spec,
  Survey Research Foundation, TestRail Scripts)
- Replace boost.lovable.app URLs with app.boostworkforce.com in Tech
  Spec and Implementation Plan
- Replace 'Built on Lovable (React/TypeScript)' with 'Built on
  React/TypeScript' in executive summary sections
- Replace 'Lovable Developer' with 'Platform Developer' throughout
  BSG Staff Training PPT (slides 31, 43)
- Add tenant.admin@boost.test (Tenant Admin, CCCOEO) to test account
  tables on slides 7, 39, 44 of BSG Staff Training PPT

Co-authored-by: Jackie Taylor <jpt@successladder.net>
</commit_message>
<xml_diff>
--- a/docs/BOOST_BSG_Staff_Training.pptx
+++ b/docs/BOOST_BSG_Staff_Training.pptx
@@ -4815,6 +4815,10 @@
             <a:prstDash val="solid"/>
           </a:ln>
         </p:spPr>
+        <p:txBody>
+          <a:bodyPr/>
+          <a:p/>
+        </p:txBody>
       </p:sp>
       <p:sp>
         <p:nvSpPr>
@@ -4840,6 +4844,10 @@
             <a:prstDash val="solid"/>
           </a:ln>
         </p:spPr>
+        <p:txBody>
+          <a:bodyPr/>
+          <a:p/>
+        </p:txBody>
       </p:sp>
       <p:sp>
         <p:nvSpPr>
@@ -5102,6 +5110,10 @@
             <a:prstDash val="solid"/>
           </a:ln>
         </p:spPr>
+        <p:txBody>
+          <a:bodyPr/>
+          <a:p/>
+        </p:txBody>
       </p:sp>
       <p:sp>
         <p:nvSpPr>
@@ -5127,6 +5139,10 @@
             <a:prstDash val="solid"/>
           </a:ln>
         </p:spPr>
+        <p:txBody>
+          <a:bodyPr/>
+          <a:p/>
+        </p:txBody>
       </p:sp>
       <p:sp>
         <p:nvSpPr>
@@ -5308,6 +5324,10 @@
             <a:prstDash val="solid"/>
           </a:ln>
         </p:spPr>
+        <p:txBody>
+          <a:bodyPr/>
+          <a:p/>
+        </p:txBody>
       </p:sp>
       <p:sp>
         <p:nvSpPr>
@@ -5545,6 +5565,10 @@
             <a:prstDash val="solid"/>
           </a:ln>
         </p:spPr>
+        <p:txBody>
+          <a:bodyPr/>
+          <a:p/>
+        </p:txBody>
       </p:sp>
       <p:sp>
         <p:nvSpPr>
@@ -5673,6 +5697,10 @@
             <a:prstDash val="solid"/>
           </a:ln>
         </p:spPr>
+        <p:txBody>
+          <a:bodyPr/>
+          <a:p/>
+        </p:txBody>
       </p:sp>
       <p:sp>
         <p:nvSpPr>
@@ -5698,6 +5726,10 @@
             <a:prstDash val="solid"/>
           </a:ln>
         </p:spPr>
+        <p:txBody>
+          <a:bodyPr/>
+          <a:p/>
+        </p:txBody>
       </p:sp>
       <p:sp>
         <p:nvSpPr>
@@ -5949,6 +5981,10 @@
             <a:prstDash val="solid"/>
           </a:ln>
         </p:spPr>
+        <p:txBody>
+          <a:bodyPr/>
+          <a:p/>
+        </p:txBody>
       </p:sp>
       <p:sp>
         <p:nvSpPr>
@@ -6013,6 +6049,10 @@
             <a:prstDash val="solid"/>
           </a:ln>
         </p:spPr>
+        <p:txBody>
+          <a:bodyPr/>
+          <a:p/>
+        </p:txBody>
       </p:sp>
       <p:sp>
         <p:nvSpPr>
@@ -6141,6 +6181,10 @@
             <a:prstDash val="solid"/>
           </a:ln>
         </p:spPr>
+        <p:txBody>
+          <a:bodyPr/>
+          <a:p/>
+        </p:txBody>
       </p:sp>
       <p:sp>
         <p:nvSpPr>
@@ -6166,6 +6210,10 @@
             <a:prstDash val="solid"/>
           </a:ln>
         </p:spPr>
+        <p:txBody>
+          <a:bodyPr/>
+          <a:p/>
+        </p:txBody>
       </p:sp>
       <p:sp>
         <p:nvSpPr>
@@ -6417,6 +6465,10 @@
             <a:prstDash val="solid"/>
           </a:ln>
         </p:spPr>
+        <p:txBody>
+          <a:bodyPr/>
+          <a:p/>
+        </p:txBody>
       </p:sp>
       <p:sp>
         <p:nvSpPr>
@@ -6481,6 +6533,10 @@
             <a:prstDash val="solid"/>
           </a:ln>
         </p:spPr>
+        <p:txBody>
+          <a:bodyPr/>
+          <a:p/>
+        </p:txBody>
       </p:sp>
       <p:sp>
         <p:nvSpPr>
@@ -6609,6 +6665,10 @@
             <a:prstDash val="solid"/>
           </a:ln>
         </p:spPr>
+        <p:txBody>
+          <a:bodyPr/>
+          <a:p/>
+        </p:txBody>
       </p:sp>
       <p:sp>
         <p:nvSpPr>
@@ -6634,6 +6694,10 @@
             <a:prstDash val="solid"/>
           </a:ln>
         </p:spPr>
+        <p:txBody>
+          <a:bodyPr/>
+          <a:p/>
+        </p:txBody>
       </p:sp>
       <p:sp>
         <p:nvSpPr>
@@ -6864,6 +6928,10 @@
             <a:prstDash val="solid"/>
           </a:ln>
         </p:spPr>
+        <p:txBody>
+          <a:bodyPr/>
+          <a:p/>
+        </p:txBody>
       </p:sp>
       <p:sp>
         <p:nvSpPr>
@@ -6928,6 +6996,10 @@
             <a:prstDash val="solid"/>
           </a:ln>
         </p:spPr>
+        <p:txBody>
+          <a:bodyPr/>
+          <a:p/>
+        </p:txBody>
       </p:sp>
       <p:sp>
         <p:nvSpPr>
@@ -7063,6 +7135,10 @@
             <a:prstDash val="solid"/>
           </a:ln>
         </p:spPr>
+        <p:txBody>
+          <a:bodyPr/>
+          <a:p/>
+        </p:txBody>
       </p:sp>
       <p:sp>
         <p:nvSpPr>
@@ -7088,6 +7164,10 @@
             <a:prstDash val="solid"/>
           </a:ln>
         </p:spPr>
+        <p:txBody>
+          <a:bodyPr/>
+          <a:p/>
+        </p:txBody>
       </p:sp>
       <p:sp>
         <p:nvSpPr>
@@ -7230,6 +7310,10 @@
             <a:prstDash val="solid"/>
           </a:ln>
         </p:spPr>
+        <p:txBody>
+          <a:bodyPr/>
+          <a:p/>
+        </p:txBody>
       </p:sp>
       <p:sp>
         <p:nvSpPr>
@@ -7358,6 +7442,10 @@
             <a:prstDash val="solid"/>
           </a:ln>
         </p:spPr>
+        <p:txBody>
+          <a:bodyPr/>
+          <a:p/>
+        </p:txBody>
       </p:sp>
       <p:sp>
         <p:nvSpPr>
@@ -7383,6 +7471,10 @@
             <a:prstDash val="solid"/>
           </a:ln>
         </p:spPr>
+        <p:txBody>
+          <a:bodyPr/>
+          <a:p/>
+        </p:txBody>
       </p:sp>
       <p:sp>
         <p:nvSpPr>
@@ -7447,6 +7539,10 @@
             <a:prstDash val="solid"/>
           </a:ln>
         </p:spPr>
+        <p:txBody>
+          <a:bodyPr/>
+          <a:p/>
+        </p:txBody>
       </p:sp>
       <p:sp>
         <p:nvSpPr>
@@ -7472,6 +7568,10 @@
             <a:prstDash val="solid"/>
           </a:ln>
         </p:spPr>
+        <p:txBody>
+          <a:bodyPr/>
+          <a:p/>
+        </p:txBody>
       </p:sp>
       <p:sp>
         <p:nvSpPr>
@@ -7497,6 +7597,10 @@
             <a:prstDash val="solid"/>
           </a:ln>
         </p:spPr>
+        <p:txBody>
+          <a:bodyPr/>
+          <a:p/>
+        </p:txBody>
       </p:sp>
       <p:sp>
         <p:nvSpPr>
@@ -7656,6 +7760,10 @@
             <a:prstDash val="solid"/>
           </a:ln>
         </p:spPr>
+        <p:txBody>
+          <a:bodyPr/>
+          <a:p/>
+        </p:txBody>
       </p:sp>
       <p:sp>
         <p:nvSpPr>
@@ -7681,6 +7789,10 @@
             <a:prstDash val="solid"/>
           </a:ln>
         </p:spPr>
+        <p:txBody>
+          <a:bodyPr/>
+          <a:p/>
+        </p:txBody>
       </p:sp>
       <p:sp>
         <p:nvSpPr>
@@ -7706,6 +7818,10 @@
             <a:prstDash val="solid"/>
           </a:ln>
         </p:spPr>
+        <p:txBody>
+          <a:bodyPr/>
+          <a:p/>
+        </p:txBody>
       </p:sp>
       <p:sp>
         <p:nvSpPr>
@@ -7882,6 +7998,10 @@
             <a:prstDash val="solid"/>
           </a:ln>
         </p:spPr>
+        <p:txBody>
+          <a:bodyPr/>
+          <a:p/>
+        </p:txBody>
       </p:sp>
       <p:sp>
         <p:nvSpPr>
@@ -7907,6 +8027,10 @@
             <a:prstDash val="solid"/>
           </a:ln>
         </p:spPr>
+        <p:txBody>
+          <a:bodyPr/>
+          <a:p/>
+        </p:txBody>
       </p:sp>
       <p:sp>
         <p:nvSpPr>
@@ -7932,6 +8056,10 @@
             <a:prstDash val="solid"/>
           </a:ln>
         </p:spPr>
+        <p:txBody>
+          <a:bodyPr/>
+          <a:p/>
+        </p:txBody>
       </p:sp>
       <p:sp>
         <p:nvSpPr>
@@ -8091,6 +8219,10 @@
             <a:prstDash val="solid"/>
           </a:ln>
         </p:spPr>
+        <p:txBody>
+          <a:bodyPr/>
+          <a:p/>
+        </p:txBody>
       </p:sp>
       <p:sp>
         <p:nvSpPr>
@@ -8116,6 +8248,10 @@
             <a:prstDash val="solid"/>
           </a:ln>
         </p:spPr>
+        <p:txBody>
+          <a:bodyPr/>
+          <a:p/>
+        </p:txBody>
       </p:sp>
       <p:sp>
         <p:nvSpPr>
@@ -8141,6 +8277,10 @@
             <a:prstDash val="solid"/>
           </a:ln>
         </p:spPr>
+        <p:txBody>
+          <a:bodyPr/>
+          <a:p/>
+        </p:txBody>
       </p:sp>
       <p:sp>
         <p:nvSpPr>
@@ -8300,6 +8440,10 @@
             <a:prstDash val="solid"/>
           </a:ln>
         </p:spPr>
+        <p:txBody>
+          <a:bodyPr/>
+          <a:p/>
+        </p:txBody>
       </p:sp>
       <p:sp>
         <p:nvSpPr>
@@ -8325,6 +8469,10 @@
             <a:prstDash val="solid"/>
           </a:ln>
         </p:spPr>
+        <p:txBody>
+          <a:bodyPr/>
+          <a:p/>
+        </p:txBody>
       </p:sp>
       <p:sp>
         <p:nvSpPr>
@@ -8350,6 +8498,10 @@
             <a:prstDash val="solid"/>
           </a:ln>
         </p:spPr>
+        <p:txBody>
+          <a:bodyPr/>
+          <a:p/>
+        </p:txBody>
       </p:sp>
       <p:sp>
         <p:nvSpPr>
@@ -8509,6 +8661,10 @@
             <a:prstDash val="solid"/>
           </a:ln>
         </p:spPr>
+        <p:txBody>
+          <a:bodyPr/>
+          <a:p/>
+        </p:txBody>
       </p:sp>
       <p:sp>
         <p:nvSpPr>
@@ -8534,6 +8690,10 @@
             <a:prstDash val="solid"/>
           </a:ln>
         </p:spPr>
+        <p:txBody>
+          <a:bodyPr/>
+          <a:p/>
+        </p:txBody>
       </p:sp>
       <p:sp>
         <p:nvSpPr>
@@ -8693,6 +8853,10 @@
             <a:prstDash val="solid"/>
           </a:ln>
         </p:spPr>
+        <p:txBody>
+          <a:bodyPr/>
+          <a:p/>
+        </p:txBody>
       </p:sp>
       <p:sp>
         <p:nvSpPr>
@@ -8821,6 +8985,10 @@
             <a:prstDash val="solid"/>
           </a:ln>
         </p:spPr>
+        <p:txBody>
+          <a:bodyPr/>
+          <a:p/>
+        </p:txBody>
       </p:sp>
       <p:sp>
         <p:nvSpPr>
@@ -8846,6 +9014,10 @@
             <a:prstDash val="solid"/>
           </a:ln>
         </p:spPr>
+        <p:txBody>
+          <a:bodyPr/>
+          <a:p/>
+        </p:txBody>
       </p:sp>
       <p:sp>
         <p:nvSpPr>
@@ -10997,6 +11169,10 @@
             <a:prstDash val="solid"/>
           </a:ln>
         </p:spPr>
+        <p:txBody>
+          <a:bodyPr/>
+          <a:p/>
+        </p:txBody>
       </p:sp>
       <p:sp>
         <p:nvSpPr>
@@ -11100,6 +11276,10 @@
             <a:prstDash val="solid"/>
           </a:ln>
         </p:spPr>
+        <p:txBody>
+          <a:bodyPr/>
+          <a:p/>
+        </p:txBody>
       </p:sp>
       <p:sp>
         <p:nvSpPr>
@@ -11228,6 +11408,10 @@
             <a:prstDash val="solid"/>
           </a:ln>
         </p:spPr>
+        <p:txBody>
+          <a:bodyPr/>
+          <a:p/>
+        </p:txBody>
       </p:sp>
       <p:sp>
         <p:nvSpPr>
@@ -11253,6 +11437,10 @@
             <a:prstDash val="solid"/>
           </a:ln>
         </p:spPr>
+        <p:txBody>
+          <a:bodyPr/>
+          <a:p/>
+        </p:txBody>
       </p:sp>
       <p:sp>
         <p:nvSpPr>
@@ -12404,6 +12592,10 @@
             <a:prstDash val="solid"/>
           </a:ln>
         </p:spPr>
+        <p:txBody>
+          <a:bodyPr/>
+          <a:p/>
+        </p:txBody>
       </p:sp>
       <p:sp>
         <p:nvSpPr>
@@ -12532,6 +12724,10 @@
             <a:prstDash val="solid"/>
           </a:ln>
         </p:spPr>
+        <p:txBody>
+          <a:bodyPr/>
+          <a:p/>
+        </p:txBody>
       </p:sp>
       <p:sp>
         <p:nvSpPr>
@@ -12557,6 +12753,10 @@
             <a:prstDash val="solid"/>
           </a:ln>
         </p:spPr>
+        <p:txBody>
+          <a:bodyPr/>
+          <a:p/>
+        </p:txBody>
       </p:sp>
       <p:sp>
         <p:nvSpPr>
@@ -13191,6 +13391,10 @@
             <a:prstDash val="solid"/>
           </a:ln>
         </p:spPr>
+        <p:txBody>
+          <a:bodyPr/>
+          <a:p/>
+        </p:txBody>
       </p:sp>
       <p:sp>
         <p:nvSpPr>
@@ -13319,6 +13523,10 @@
             <a:prstDash val="solid"/>
           </a:ln>
         </p:spPr>
+        <p:txBody>
+          <a:bodyPr/>
+          <a:p/>
+        </p:txBody>
       </p:sp>
       <p:sp>
         <p:nvSpPr>
@@ -13344,6 +13552,10 @@
             <a:prstDash val="solid"/>
           </a:ln>
         </p:spPr>
+        <p:txBody>
+          <a:bodyPr/>
+          <a:p/>
+        </p:txBody>
       </p:sp>
       <p:sp>
         <p:nvSpPr>
@@ -14020,6 +14232,10 @@
             <a:prstDash val="solid"/>
           </a:ln>
         </p:spPr>
+        <p:txBody>
+          <a:bodyPr/>
+          <a:p/>
+        </p:txBody>
       </p:sp>
       <p:sp>
         <p:nvSpPr>
@@ -14148,6 +14364,10 @@
             <a:prstDash val="solid"/>
           </a:ln>
         </p:spPr>
+        <p:txBody>
+          <a:bodyPr/>
+          <a:p/>
+        </p:txBody>
       </p:sp>
       <p:sp>
         <p:nvSpPr>
@@ -14173,6 +14393,10 @@
             <a:prstDash val="solid"/>
           </a:ln>
         </p:spPr>
+        <p:txBody>
+          <a:bodyPr/>
+          <a:p/>
+        </p:txBody>
       </p:sp>
       <p:sp>
         <p:nvSpPr>
@@ -14396,6 +14620,10 @@
             <a:prstDash val="solid"/>
           </a:ln>
         </p:spPr>
+        <p:txBody>
+          <a:bodyPr/>
+          <a:p/>
+        </p:txBody>
       </p:sp>
       <p:sp>
         <p:nvSpPr>
@@ -14516,6 +14744,10 @@
             <a:prstDash val="solid"/>
           </a:ln>
         </p:spPr>
+        <p:txBody>
+          <a:bodyPr/>
+          <a:p/>
+        </p:txBody>
       </p:sp>
       <p:sp>
         <p:nvSpPr>
@@ -14636,6 +14868,10 @@
             <a:prstDash val="solid"/>
           </a:ln>
         </p:spPr>
+        <p:txBody>
+          <a:bodyPr/>
+          <a:p/>
+        </p:txBody>
       </p:sp>
       <p:sp>
         <p:nvSpPr>
@@ -14756,6 +14992,10 @@
             <a:prstDash val="solid"/>
           </a:ln>
         </p:spPr>
+        <p:txBody>
+          <a:bodyPr/>
+          <a:p/>
+        </p:txBody>
       </p:sp>
       <p:sp>
         <p:nvSpPr>
@@ -14884,6 +15124,10 @@
             <a:prstDash val="solid"/>
           </a:ln>
         </p:spPr>
+        <p:txBody>
+          <a:bodyPr/>
+          <a:p/>
+        </p:txBody>
       </p:sp>
       <p:sp>
         <p:nvSpPr>
@@ -14909,6 +15153,10 @@
             <a:prstDash val="solid"/>
           </a:ln>
         </p:spPr>
+        <p:txBody>
+          <a:bodyPr/>
+          <a:p/>
+        </p:txBody>
       </p:sp>
       <p:sp>
         <p:nvSpPr>
@@ -15224,6 +15472,10 @@
             <a:prstDash val="solid"/>
           </a:ln>
         </p:spPr>
+        <p:txBody>
+          <a:bodyPr/>
+          <a:p/>
+        </p:txBody>
       </p:sp>
       <p:sp>
         <p:nvSpPr>
@@ -15288,6 +15540,10 @@
             <a:prstDash val="solid"/>
           </a:ln>
         </p:spPr>
+        <p:txBody>
+          <a:bodyPr/>
+          <a:p/>
+        </p:txBody>
       </p:sp>
       <p:sp>
         <p:nvSpPr>
@@ -15416,6 +15672,10 @@
             <a:prstDash val="solid"/>
           </a:ln>
         </p:spPr>
+        <p:txBody>
+          <a:bodyPr/>
+          <a:p/>
+        </p:txBody>
       </p:sp>
       <p:sp>
         <p:nvSpPr>
@@ -15441,6 +15701,10 @@
             <a:prstDash val="solid"/>
           </a:ln>
         </p:spPr>
+        <p:txBody>
+          <a:bodyPr/>
+          <a:p/>
+        </p:txBody>
       </p:sp>
       <p:sp>
         <p:nvSpPr>
@@ -15692,6 +15956,10 @@
             <a:prstDash val="solid"/>
           </a:ln>
         </p:spPr>
+        <p:txBody>
+          <a:bodyPr/>
+          <a:p/>
+        </p:txBody>
       </p:sp>
       <p:sp>
         <p:nvSpPr>
@@ -15773,6 +16041,10 @@
             <a:prstDash val="solid"/>
           </a:ln>
         </p:spPr>
+        <p:txBody>
+          <a:bodyPr/>
+          <a:p/>
+        </p:txBody>
       </p:sp>
       <p:sp>
         <p:nvSpPr>
@@ -15854,6 +16126,10 @@
             <a:prstDash val="solid"/>
           </a:ln>
         </p:spPr>
+        <p:txBody>
+          <a:bodyPr/>
+          <a:p/>
+        </p:txBody>
       </p:sp>
       <p:sp>
         <p:nvSpPr>
@@ -15989,6 +16265,10 @@
             <a:prstDash val="solid"/>
           </a:ln>
         </p:spPr>
+        <p:txBody>
+          <a:bodyPr/>
+          <a:p/>
+        </p:txBody>
       </p:sp>
       <p:sp>
         <p:nvSpPr>
@@ -16014,6 +16294,10 @@
             <a:prstDash val="solid"/>
           </a:ln>
         </p:spPr>
+        <p:txBody>
+          <a:bodyPr/>
+          <a:p/>
+        </p:txBody>
       </p:sp>
       <p:sp>
         <p:nvSpPr>
@@ -16156,6 +16440,10 @@
             <a:prstDash val="solid"/>
           </a:ln>
         </p:spPr>
+        <p:txBody>
+          <a:bodyPr/>
+          <a:p/>
+        </p:txBody>
       </p:sp>
       <p:sp>
         <p:nvSpPr>
@@ -16284,6 +16572,10 @@
             <a:prstDash val="solid"/>
           </a:ln>
         </p:spPr>
+        <p:txBody>
+          <a:bodyPr/>
+          <a:p/>
+        </p:txBody>
       </p:sp>
       <p:sp>
         <p:nvSpPr>
@@ -16309,6 +16601,10 @@
             <a:prstDash val="solid"/>
           </a:ln>
         </p:spPr>
+        <p:txBody>
+          <a:bodyPr/>
+          <a:p/>
+        </p:txBody>
       </p:sp>
       <p:sp>
         <p:nvSpPr>
@@ -16373,6 +16669,10 @@
             <a:prstDash val="solid"/>
           </a:ln>
         </p:spPr>
+        <p:txBody>
+          <a:bodyPr/>
+          <a:p/>
+        </p:txBody>
       </p:sp>
       <p:sp>
         <p:nvSpPr>
@@ -16398,6 +16698,10 @@
             <a:prstDash val="solid"/>
           </a:ln>
         </p:spPr>
+        <p:txBody>
+          <a:bodyPr/>
+          <a:p/>
+        </p:txBody>
       </p:sp>
       <p:sp>
         <p:nvSpPr>
@@ -16557,6 +16861,10 @@
             <a:prstDash val="solid"/>
           </a:ln>
         </p:spPr>
+        <p:txBody>
+          <a:bodyPr/>
+          <a:p/>
+        </p:txBody>
       </p:sp>
       <p:sp>
         <p:nvSpPr>
@@ -16582,6 +16890,10 @@
             <a:prstDash val="solid"/>
           </a:ln>
         </p:spPr>
+        <p:txBody>
+          <a:bodyPr/>
+          <a:p/>
+        </p:txBody>
       </p:sp>
       <p:sp>
         <p:nvSpPr>
@@ -16741,6 +17053,10 @@
             <a:prstDash val="solid"/>
           </a:ln>
         </p:spPr>
+        <p:txBody>
+          <a:bodyPr/>
+          <a:p/>
+        </p:txBody>
       </p:sp>
       <p:sp>
         <p:nvSpPr>
@@ -16766,6 +17082,10 @@
             <a:prstDash val="solid"/>
           </a:ln>
         </p:spPr>
+        <p:txBody>
+          <a:bodyPr/>
+          <a:p/>
+        </p:txBody>
       </p:sp>
       <p:sp>
         <p:nvSpPr>
@@ -16908,6 +17228,10 @@
             <a:prstDash val="solid"/>
           </a:ln>
         </p:spPr>
+        <p:txBody>
+          <a:bodyPr/>
+          <a:p/>
+        </p:txBody>
       </p:sp>
       <p:sp>
         <p:nvSpPr>
@@ -16933,6 +17257,10 @@
             <a:prstDash val="solid"/>
           </a:ln>
         </p:spPr>
+        <p:txBody>
+          <a:bodyPr/>
+          <a:p/>
+        </p:txBody>
       </p:sp>
       <p:sp>
         <p:nvSpPr>
@@ -17075,6 +17403,10 @@
             <a:prstDash val="solid"/>
           </a:ln>
         </p:spPr>
+        <p:txBody>
+          <a:bodyPr/>
+          <a:p/>
+        </p:txBody>
       </p:sp>
       <p:sp>
         <p:nvSpPr>
@@ -17203,6 +17535,10 @@
             <a:prstDash val="solid"/>
           </a:ln>
         </p:spPr>
+        <p:txBody>
+          <a:bodyPr/>
+          <a:p/>
+        </p:txBody>
       </p:sp>
       <p:sp>
         <p:nvSpPr>
@@ -17228,6 +17564,10 @@
             <a:prstDash val="solid"/>
           </a:ln>
         </p:spPr>
+        <p:txBody>
+          <a:bodyPr/>
+          <a:p/>
+        </p:txBody>
       </p:sp>
       <p:sp>
         <p:nvSpPr>
@@ -17292,6 +17632,10 @@
             <a:prstDash val="solid"/>
           </a:ln>
         </p:spPr>
+        <p:txBody>
+          <a:bodyPr/>
+          <a:p/>
+        </p:txBody>
       </p:sp>
       <p:sp>
         <p:nvSpPr>
@@ -17317,6 +17661,10 @@
             <a:prstDash val="solid"/>
           </a:ln>
         </p:spPr>
+        <p:txBody>
+          <a:bodyPr/>
+          <a:p/>
+        </p:txBody>
       </p:sp>
       <p:sp>
         <p:nvSpPr>
@@ -17476,6 +17824,10 @@
             <a:prstDash val="solid"/>
           </a:ln>
         </p:spPr>
+        <p:txBody>
+          <a:bodyPr/>
+          <a:p/>
+        </p:txBody>
       </p:sp>
       <p:sp>
         <p:nvSpPr>
@@ -17501,6 +17853,10 @@
             <a:prstDash val="solid"/>
           </a:ln>
         </p:spPr>
+        <p:txBody>
+          <a:bodyPr/>
+          <a:p/>
+        </p:txBody>
       </p:sp>
       <p:sp>
         <p:nvSpPr>
@@ -17660,6 +18016,10 @@
             <a:prstDash val="solid"/>
           </a:ln>
         </p:spPr>
+        <p:txBody>
+          <a:bodyPr/>
+          <a:p/>
+        </p:txBody>
       </p:sp>
       <p:sp>
         <p:nvSpPr>
@@ -17685,6 +18045,10 @@
             <a:prstDash val="solid"/>
           </a:ln>
         </p:spPr>
+        <p:txBody>
+          <a:bodyPr/>
+          <a:p/>
+        </p:txBody>
       </p:sp>
       <p:sp>
         <p:nvSpPr>
@@ -17844,6 +18208,10 @@
             <a:prstDash val="solid"/>
           </a:ln>
         </p:spPr>
+        <p:txBody>
+          <a:bodyPr/>
+          <a:p/>
+        </p:txBody>
       </p:sp>
       <p:sp>
         <p:nvSpPr>
@@ -17869,6 +18237,10 @@
             <a:prstDash val="solid"/>
           </a:ln>
         </p:spPr>
+        <p:txBody>
+          <a:bodyPr/>
+          <a:p/>
+        </p:txBody>
       </p:sp>
       <p:sp>
         <p:nvSpPr>
@@ -18028,6 +18400,10 @@
             <a:prstDash val="solid"/>
           </a:ln>
         </p:spPr>
+        <p:txBody>
+          <a:bodyPr/>
+          <a:p/>
+        </p:txBody>
       </p:sp>
       <p:sp>
         <p:nvSpPr>
@@ -18156,6 +18532,10 @@
             <a:prstDash val="solid"/>
           </a:ln>
         </p:spPr>
+        <p:txBody>
+          <a:bodyPr/>
+          <a:p/>
+        </p:txBody>
       </p:sp>
       <p:sp>
         <p:nvSpPr>
@@ -18181,6 +18561,10 @@
             <a:prstDash val="solid"/>
           </a:ln>
         </p:spPr>
+        <p:txBody>
+          <a:bodyPr/>
+          <a:p/>
+        </p:txBody>
       </p:sp>
       <p:sp>
         <p:nvSpPr>
@@ -18457,6 +18841,10 @@
             <a:prstDash val="solid"/>
           </a:ln>
         </p:spPr>
+        <p:txBody>
+          <a:bodyPr/>
+          <a:p/>
+        </p:txBody>
       </p:sp>
       <p:sp>
         <p:nvSpPr>
@@ -18521,6 +18909,10 @@
             <a:prstDash val="solid"/>
           </a:ln>
         </p:spPr>
+        <p:txBody>
+          <a:bodyPr/>
+          <a:p/>
+        </p:txBody>
       </p:sp>
       <p:sp>
         <p:nvSpPr>
@@ -18649,6 +19041,10 @@
             <a:prstDash val="solid"/>
           </a:ln>
         </p:spPr>
+        <p:txBody>
+          <a:bodyPr/>
+          <a:p/>
+        </p:txBody>
       </p:sp>
       <p:sp>
         <p:nvSpPr>
@@ -18674,6 +19070,10 @@
             <a:prstDash val="solid"/>
           </a:ln>
         </p:spPr>
+        <p:txBody>
+          <a:bodyPr/>
+          <a:p/>
+        </p:txBody>
       </p:sp>
       <p:sp>
         <p:nvSpPr>
@@ -18950,6 +19350,10 @@
             <a:prstDash val="solid"/>
           </a:ln>
         </p:spPr>
+        <p:txBody>
+          <a:bodyPr/>
+          <a:p/>
+        </p:txBody>
       </p:sp>
       <p:sp>
         <p:nvSpPr>
@@ -19014,6 +19418,10 @@
             <a:prstDash val="solid"/>
           </a:ln>
         </p:spPr>
+        <p:txBody>
+          <a:bodyPr/>
+          <a:p/>
+        </p:txBody>
       </p:sp>
       <p:sp>
         <p:nvSpPr>
@@ -19142,6 +19550,10 @@
             <a:prstDash val="solid"/>
           </a:ln>
         </p:spPr>
+        <p:txBody>
+          <a:bodyPr/>
+          <a:p/>
+        </p:txBody>
       </p:sp>
       <p:sp>
         <p:nvSpPr>
@@ -19167,6 +19579,10 @@
             <a:prstDash val="solid"/>
           </a:ln>
         </p:spPr>
+        <p:txBody>
+          <a:bodyPr/>
+          <a:p/>
+        </p:txBody>
       </p:sp>
       <p:sp>
         <p:nvSpPr>
@@ -19348,6 +19764,10 @@
             <a:prstDash val="solid"/>
           </a:ln>
         </p:spPr>
+        <p:txBody>
+          <a:bodyPr/>
+          <a:p/>
+        </p:txBody>
       </p:sp>
       <p:sp>
         <p:nvSpPr>
@@ -19627,6 +20047,10 @@
             <a:prstDash val="solid"/>
           </a:ln>
         </p:spPr>
+        <p:txBody>
+          <a:bodyPr/>
+          <a:p/>
+        </p:txBody>
       </p:sp>
       <p:sp>
         <p:nvSpPr>
@@ -19755,6 +20179,10 @@
             <a:prstDash val="solid"/>
           </a:ln>
         </p:spPr>
+        <p:txBody>
+          <a:bodyPr/>
+          <a:p/>
+        </p:txBody>
       </p:sp>
       <p:sp>
         <p:nvSpPr>
@@ -19780,6 +20208,10 @@
             <a:prstDash val="solid"/>
           </a:ln>
         </p:spPr>
+        <p:txBody>
+          <a:bodyPr/>
+          <a:p/>
+        </p:txBody>
       </p:sp>
       <p:sp>
         <p:nvSpPr>
@@ -20056,6 +20488,10 @@
             <a:prstDash val="solid"/>
           </a:ln>
         </p:spPr>
+        <p:txBody>
+          <a:bodyPr/>
+          <a:p/>
+        </p:txBody>
       </p:sp>
       <p:sp>
         <p:nvSpPr>
@@ -20120,6 +20556,10 @@
             <a:prstDash val="solid"/>
           </a:ln>
         </p:spPr>
+        <p:txBody>
+          <a:bodyPr/>
+          <a:p/>
+        </p:txBody>
       </p:sp>
       <p:sp>
         <p:nvSpPr>
@@ -20248,6 +20688,10 @@
             <a:prstDash val="solid"/>
           </a:ln>
         </p:spPr>
+        <p:txBody>
+          <a:bodyPr/>
+          <a:p/>
+        </p:txBody>
       </p:sp>
       <p:sp>
         <p:nvSpPr>
@@ -20273,6 +20717,10 @@
             <a:prstDash val="solid"/>
           </a:ln>
         </p:spPr>
+        <p:txBody>
+          <a:bodyPr/>
+          <a:p/>
+        </p:txBody>
       </p:sp>
       <p:sp>
         <p:nvSpPr>
@@ -20549,6 +20997,10 @@
             <a:prstDash val="solid"/>
           </a:ln>
         </p:spPr>
+        <p:txBody>
+          <a:bodyPr/>
+          <a:p/>
+        </p:txBody>
       </p:sp>
       <p:sp>
         <p:nvSpPr>
@@ -20613,6 +21065,10 @@
             <a:prstDash val="solid"/>
           </a:ln>
         </p:spPr>
+        <p:txBody>
+          <a:bodyPr/>
+          <a:p/>
+        </p:txBody>
       </p:sp>
       <p:sp>
         <p:nvSpPr>
@@ -20741,6 +21197,10 @@
             <a:prstDash val="solid"/>
           </a:ln>
         </p:spPr>
+        <p:txBody>
+          <a:bodyPr/>
+          <a:p/>
+        </p:txBody>
       </p:sp>
       <p:sp>
         <p:nvSpPr>
@@ -20766,6 +21226,10 @@
             <a:prstDash val="solid"/>
           </a:ln>
         </p:spPr>
+        <p:txBody>
+          <a:bodyPr/>
+          <a:p/>
+        </p:txBody>
       </p:sp>
       <p:sp>
         <p:nvSpPr>
@@ -21056,6 +21520,10 @@
             <a:prstDash val="solid"/>
           </a:ln>
         </p:spPr>
+        <p:txBody>
+          <a:bodyPr/>
+          <a:p/>
+        </p:txBody>
       </p:sp>
       <p:sp>
         <p:nvSpPr>
@@ -21184,6 +21652,10 @@
             <a:prstDash val="solid"/>
           </a:ln>
         </p:spPr>
+        <p:txBody>
+          <a:bodyPr/>
+          <a:p/>
+        </p:txBody>
       </p:sp>
       <p:sp>
         <p:nvSpPr>
@@ -21209,6 +21681,10 @@
             <a:prstDash val="solid"/>
           </a:ln>
         </p:spPr>
+        <p:txBody>
+          <a:bodyPr/>
+          <a:p/>
+        </p:txBody>
       </p:sp>
       <p:sp>
         <p:nvSpPr>
@@ -23525,6 +24001,10 @@
             <a:prstDash val="solid"/>
           </a:ln>
         </p:spPr>
+        <p:txBody>
+          <a:bodyPr/>
+          <a:p/>
+        </p:txBody>
       </p:sp>
       <p:sp>
         <p:nvSpPr>
@@ -23653,6 +24133,10 @@
             <a:prstDash val="solid"/>
           </a:ln>
         </p:spPr>
+        <p:txBody>
+          <a:bodyPr/>
+          <a:p/>
+        </p:txBody>
       </p:sp>
       <p:sp>
         <p:nvSpPr>
@@ -23678,6 +24162,10 @@
             <a:prstDash val="solid"/>
           </a:ln>
         </p:spPr>
+        <p:txBody>
+          <a:bodyPr/>
+          <a:p/>
+        </p:txBody>
       </p:sp>
       <p:sp>
         <p:nvSpPr>
@@ -23742,6 +24230,10 @@
             <a:prstDash val="solid"/>
           </a:ln>
         </p:spPr>
+        <p:txBody>
+          <a:bodyPr/>
+          <a:p/>
+        </p:txBody>
       </p:sp>
       <p:sp>
         <p:nvSpPr>
@@ -23767,6 +24259,10 @@
             <a:prstDash val="solid"/>
           </a:ln>
         </p:spPr>
+        <p:txBody>
+          <a:bodyPr/>
+          <a:p/>
+        </p:txBody>
       </p:sp>
       <p:sp>
         <p:nvSpPr>
@@ -23948,6 +24444,10 @@
             <a:prstDash val="solid"/>
           </a:ln>
         </p:spPr>
+        <p:txBody>
+          <a:bodyPr/>
+          <a:p/>
+        </p:txBody>
       </p:sp>
       <p:sp>
         <p:nvSpPr>
@@ -23973,6 +24473,10 @@
             <a:prstDash val="solid"/>
           </a:ln>
         </p:spPr>
+        <p:txBody>
+          <a:bodyPr/>
+          <a:p/>
+        </p:txBody>
       </p:sp>
       <p:sp>
         <p:nvSpPr>
@@ -24154,6 +24658,10 @@
             <a:prstDash val="solid"/>
           </a:ln>
         </p:spPr>
+        <p:txBody>
+          <a:bodyPr/>
+          <a:p/>
+        </p:txBody>
       </p:sp>
       <p:sp>
         <p:nvSpPr>
@@ -24179,6 +24687,10 @@
             <a:prstDash val="solid"/>
           </a:ln>
         </p:spPr>
+        <p:txBody>
+          <a:bodyPr/>
+          <a:p/>
+        </p:txBody>
       </p:sp>
       <p:sp>
         <p:nvSpPr>
@@ -24252,7 +24764,7 @@
                 <a:ea typeface="Calibri" pitchFamily="34" charset="-122"/>
                 <a:cs typeface="Calibri" pitchFamily="34" charset="-120"/>
               </a:rPr>
-              <a:t>Lovable Developer</a:t>
+              <a:t>Platform Developer</a:t>
             </a:r>
             <a:endParaRPr lang="en-US" sz="900" dirty="0"/>
           </a:p>
@@ -24291,7 +24803,7 @@
                 <a:ea typeface="Trebuchet MS" pitchFamily="34" charset="-122"/>
                 <a:cs typeface="Trebuchet MS" pitchFamily="34" charset="-120"/>
               </a:rPr>
-              <a:t>Lovable Developer</a:t>
+              <a:t>Platform Developer</a:t>
             </a:r>
             <a:endParaRPr lang="en-US" sz="1500" dirty="0"/>
           </a:p>
@@ -24360,6 +24872,10 @@
             <a:prstDash val="solid"/>
           </a:ln>
         </p:spPr>
+        <p:txBody>
+          <a:bodyPr/>
+          <a:p/>
+        </p:txBody>
       </p:sp>
       <p:sp>
         <p:nvSpPr>
@@ -24394,7 +24910,7 @@
                 <a:ea typeface="Calibri" pitchFamily="34" charset="-122"/>
                 <a:cs typeface="Calibri" pitchFamily="34" charset="-120"/>
               </a:rPr>
-              <a:t>NEVER promise a bug fix timeline without first confirming with the Lovable Developer.</a:t>
+              <a:t>NEVER promise a bug fix timeline without first confirming with the Platform Developer.</a:t>
             </a:r>
             <a:endParaRPr lang="en-US" sz="1200" dirty="0"/>
           </a:p>
@@ -24424,6 +24940,10 @@
             <a:prstDash val="solid"/>
           </a:ln>
         </p:spPr>
+        <p:txBody>
+          <a:bodyPr/>
+          <a:p/>
+        </p:txBody>
       </p:sp>
       <p:sp>
         <p:nvSpPr>
@@ -24552,6 +25072,10 @@
             <a:prstDash val="solid"/>
           </a:ln>
         </p:spPr>
+        <p:txBody>
+          <a:bodyPr/>
+          <a:p/>
+        </p:txBody>
       </p:sp>
       <p:sp>
         <p:nvSpPr>
@@ -24577,6 +25101,10 @@
             <a:prstDash val="solid"/>
           </a:ln>
         </p:spPr>
+        <p:txBody>
+          <a:bodyPr/>
+          <a:p/>
+        </p:txBody>
       </p:sp>
       <p:sp>
         <p:nvSpPr>
@@ -25881,6 +26409,10 @@
             <a:prstDash val="solid"/>
           </a:ln>
         </p:spPr>
+        <p:txBody>
+          <a:bodyPr/>
+          <a:p/>
+        </p:txBody>
       </p:sp>
       <p:sp>
         <p:nvSpPr>
@@ -26009,6 +26541,10 @@
             <a:prstDash val="solid"/>
           </a:ln>
         </p:spPr>
+        <p:txBody>
+          <a:bodyPr/>
+          <a:p/>
+        </p:txBody>
       </p:sp>
       <p:sp>
         <p:nvSpPr>
@@ -26034,6 +26570,10 @@
             <a:prstDash val="solid"/>
           </a:ln>
         </p:spPr>
+        <p:txBody>
+          <a:bodyPr/>
+          <a:p/>
+        </p:txBody>
       </p:sp>
       <p:sp>
         <p:nvSpPr>
@@ -26098,6 +26638,10 @@
             <a:prstDash val="solid"/>
           </a:ln>
         </p:spPr>
+        <p:txBody>
+          <a:bodyPr/>
+          <a:p/>
+        </p:txBody>
       </p:sp>
       <p:sp>
         <p:nvSpPr>
@@ -26201,6 +26745,10 @@
             <a:prstDash val="solid"/>
           </a:ln>
         </p:spPr>
+        <p:txBody>
+          <a:bodyPr/>
+          <a:p/>
+        </p:txBody>
       </p:sp>
       <p:sp>
         <p:nvSpPr>
@@ -26304,6 +26852,10 @@
             <a:prstDash val="solid"/>
           </a:ln>
         </p:spPr>
+        <p:txBody>
+          <a:bodyPr/>
+          <a:p/>
+        </p:txBody>
       </p:sp>
       <p:sp>
         <p:nvSpPr>
@@ -26407,6 +26959,10 @@
             <a:prstDash val="solid"/>
           </a:ln>
         </p:spPr>
+        <p:txBody>
+          <a:bodyPr/>
+          <a:p/>
+        </p:txBody>
       </p:sp>
       <p:sp>
         <p:nvSpPr>
@@ -26542,6 +27098,10 @@
             <a:prstDash val="solid"/>
           </a:ln>
         </p:spPr>
+        <p:txBody>
+          <a:bodyPr/>
+          <a:p/>
+        </p:txBody>
       </p:sp>
       <p:sp>
         <p:nvSpPr>
@@ -26567,6 +27127,10 @@
             <a:prstDash val="solid"/>
           </a:ln>
         </p:spPr>
+        <p:txBody>
+          <a:bodyPr/>
+          <a:p/>
+        </p:txBody>
       </p:sp>
       <p:sp>
         <p:nvSpPr>
@@ -26709,6 +27273,10 @@
             <a:prstDash val="solid"/>
           </a:ln>
         </p:spPr>
+        <p:txBody>
+          <a:bodyPr/>
+          <a:p/>
+        </p:txBody>
       </p:sp>
       <p:sp>
         <p:nvSpPr>
@@ -26837,6 +27405,10 @@
             <a:prstDash val="solid"/>
           </a:ln>
         </p:spPr>
+        <p:txBody>
+          <a:bodyPr/>
+          <a:p/>
+        </p:txBody>
       </p:sp>
       <p:sp>
         <p:nvSpPr>
@@ -26862,6 +27434,10 @@
             <a:prstDash val="solid"/>
           </a:ln>
         </p:spPr>
+        <p:txBody>
+          <a:bodyPr/>
+          <a:p/>
+        </p:txBody>
       </p:sp>
       <p:sp>
         <p:nvSpPr>
@@ -27180,6 +27756,10 @@
             <a:prstDash val="solid"/>
           </a:ln>
         </p:spPr>
+        <p:txBody>
+          <a:bodyPr/>
+          <a:p/>
+        </p:txBody>
       </p:sp>
       <p:sp>
         <p:nvSpPr>
@@ -27308,6 +27888,10 @@
             <a:prstDash val="solid"/>
           </a:ln>
         </p:spPr>
+        <p:txBody>
+          <a:bodyPr/>
+          <a:p/>
+        </p:txBody>
       </p:sp>
       <p:sp>
         <p:nvSpPr>
@@ -27333,6 +27917,10 @@
             <a:prstDash val="solid"/>
           </a:ln>
         </p:spPr>
+        <p:txBody>
+          <a:bodyPr/>
+          <a:p/>
+        </p:txBody>
       </p:sp>
       <p:sp>
         <p:nvSpPr>
@@ -28676,6 +29264,10 @@
             <a:prstDash val="solid"/>
           </a:ln>
         </p:spPr>
+        <p:txBody>
+          <a:bodyPr/>
+          <a:p/>
+        </p:txBody>
       </p:sp>
       <p:sp>
         <p:nvSpPr>
@@ -28740,6 +29332,10 @@
             <a:prstDash val="solid"/>
           </a:ln>
         </p:spPr>
+        <p:txBody>
+          <a:bodyPr/>
+          <a:p/>
+        </p:txBody>
       </p:sp>
       <p:sp>
         <p:nvSpPr>
@@ -28868,6 +29464,10 @@
             <a:prstDash val="solid"/>
           </a:ln>
         </p:spPr>
+        <p:txBody>
+          <a:bodyPr/>
+          <a:p/>
+        </p:txBody>
       </p:sp>
       <p:sp>
         <p:nvSpPr>
@@ -28893,6 +29493,10 @@
             <a:prstDash val="solid"/>
           </a:ln>
         </p:spPr>
+        <p:txBody>
+          <a:bodyPr/>
+          <a:p/>
+        </p:txBody>
       </p:sp>
       <p:sp>
         <p:nvSpPr>
@@ -28957,6 +29561,10 @@
             <a:prstDash val="solid"/>
           </a:ln>
         </p:spPr>
+        <p:txBody>
+          <a:bodyPr/>
+          <a:p/>
+        </p:txBody>
       </p:sp>
       <p:sp>
         <p:nvSpPr>
@@ -28982,6 +29590,10 @@
             <a:prstDash val="solid"/>
           </a:ln>
         </p:spPr>
+        <p:txBody>
+          <a:bodyPr/>
+          <a:p/>
+        </p:txBody>
       </p:sp>
       <p:sp>
         <p:nvSpPr>
@@ -29085,6 +29697,10 @@
             <a:prstDash val="solid"/>
           </a:ln>
         </p:spPr>
+        <p:txBody>
+          <a:bodyPr/>
+          <a:p/>
+        </p:txBody>
       </p:sp>
       <p:sp>
         <p:nvSpPr>
@@ -29110,6 +29726,10 @@
             <a:prstDash val="solid"/>
           </a:ln>
         </p:spPr>
+        <p:txBody>
+          <a:bodyPr/>
+          <a:p/>
+        </p:txBody>
       </p:sp>
       <p:sp>
         <p:nvSpPr>
@@ -29213,6 +29833,10 @@
             <a:prstDash val="solid"/>
           </a:ln>
         </p:spPr>
+        <p:txBody>
+          <a:bodyPr/>
+          <a:p/>
+        </p:txBody>
       </p:sp>
       <p:sp>
         <p:nvSpPr>
@@ -29238,6 +29862,10 @@
             <a:prstDash val="solid"/>
           </a:ln>
         </p:spPr>
+        <p:txBody>
+          <a:bodyPr/>
+          <a:p/>
+        </p:txBody>
       </p:sp>
       <p:sp>
         <p:nvSpPr>
@@ -29341,6 +29969,10 @@
             <a:prstDash val="solid"/>
           </a:ln>
         </p:spPr>
+        <p:txBody>
+          <a:bodyPr/>
+          <a:p/>
+        </p:txBody>
       </p:sp>
       <p:sp>
         <p:nvSpPr>
@@ -29366,6 +29998,10 @@
             <a:prstDash val="solid"/>
           </a:ln>
         </p:spPr>
+        <p:txBody>
+          <a:bodyPr/>
+          <a:p/>
+        </p:txBody>
       </p:sp>
       <p:sp>
         <p:nvSpPr>
@@ -29469,6 +30105,10 @@
             <a:prstDash val="solid"/>
           </a:ln>
         </p:spPr>
+        <p:txBody>
+          <a:bodyPr/>
+          <a:p/>
+        </p:txBody>
       </p:sp>
       <p:sp>
         <p:nvSpPr>
@@ -29597,6 +30237,10 @@
             <a:prstDash val="solid"/>
           </a:ln>
         </p:spPr>
+        <p:txBody>
+          <a:bodyPr/>
+          <a:p/>
+        </p:txBody>
       </p:sp>
       <p:sp>
         <p:nvSpPr>
@@ -29622,6 +30266,10 @@
             <a:prstDash val="solid"/>
           </a:ln>
         </p:spPr>
+        <p:txBody>
+          <a:bodyPr/>
+          <a:p/>
+        </p:txBody>
       </p:sp>
       <p:sp>
         <p:nvSpPr>
@@ -29961,6 +30609,10 @@
             <a:prstDash val="solid"/>
           </a:ln>
         </p:spPr>
+        <p:txBody>
+          <a:bodyPr/>
+          <a:p/>
+        </p:txBody>
       </p:sp>
       <p:sp>
         <p:nvSpPr>
@@ -30089,6 +30741,10 @@
             <a:prstDash val="solid"/>
           </a:ln>
         </p:spPr>
+        <p:txBody>
+          <a:bodyPr/>
+          <a:p/>
+        </p:txBody>
       </p:sp>
       <p:sp>
         <p:nvSpPr>
@@ -30114,6 +30770,10 @@
             <a:prstDash val="solid"/>
           </a:ln>
         </p:spPr>
+        <p:txBody>
+          <a:bodyPr/>
+          <a:p/>
+        </p:txBody>
       </p:sp>
       <p:sp>
         <p:nvSpPr>
@@ -30326,6 +30986,10 @@
             <a:prstDash val="solid"/>
           </a:ln>
         </p:spPr>
+        <p:txBody>
+          <a:bodyPr/>
+          <a:p/>
+        </p:txBody>
       </p:sp>
       <p:sp>
         <p:nvSpPr>
@@ -30360,7 +31024,7 @@
                 <a:ea typeface="Calibri" pitchFamily="34" charset="-122"/>
                 <a:cs typeface="Calibri" pitchFamily="34" charset="-120"/>
               </a:rPr>
-              <a:t>Test accounts: admin@boost.test (Tenant Admin, CCCOEO tenant) | learner@boost.test (Learner, CCCOEO tenant)</a:t>
+              <a:t>Test accounts: admin@boost.test (BSG Admin, CCCOEO tenant) | tenant.admin@boost.test (Tenant Admin, CCCOEO tenant) | learner@boost.test (Learner, CCCOEO tenant)</a:t>
             </a:r>
             <a:endParaRPr lang="en-US" sz="1200" dirty="0"/>
           </a:p>
@@ -30390,6 +31054,10 @@
             <a:prstDash val="solid"/>
           </a:ln>
         </p:spPr>
+        <p:txBody>
+          <a:bodyPr/>
+          <a:p/>
+        </p:txBody>
       </p:sp>
       <p:sp>
         <p:nvSpPr>
@@ -30518,6 +31186,10 @@
             <a:prstDash val="solid"/>
           </a:ln>
         </p:spPr>
+        <p:txBody>
+          <a:bodyPr/>
+          <a:p/>
+        </p:txBody>
       </p:sp>
       <p:sp>
         <p:nvSpPr>
@@ -30543,6 +31215,10 @@
             <a:prstDash val="solid"/>
           </a:ln>
         </p:spPr>
+        <p:txBody>
+          <a:bodyPr/>
+          <a:p/>
+        </p:txBody>
       </p:sp>
       <p:sp>
         <p:nvSpPr>
@@ -30607,6 +31283,10 @@
             <a:prstDash val="solid"/>
           </a:ln>
         </p:spPr>
+        <p:txBody>
+          <a:bodyPr/>
+          <a:p/>
+        </p:txBody>
       </p:sp>
       <p:sp>
         <p:nvSpPr>
@@ -30632,6 +31312,10 @@
             <a:prstDash val="solid"/>
           </a:ln>
         </p:spPr>
+        <p:txBody>
+          <a:bodyPr/>
+          <a:p/>
+        </p:txBody>
       </p:sp>
       <p:sp>
         <p:nvSpPr>
@@ -30769,6 +31453,10 @@
             <a:prstDash val="solid"/>
           </a:ln>
         </p:spPr>
+        <p:txBody>
+          <a:bodyPr/>
+          <a:p/>
+        </p:txBody>
       </p:sp>
       <p:sp>
         <p:nvSpPr>
@@ -30794,6 +31482,10 @@
             <a:prstDash val="solid"/>
           </a:ln>
         </p:spPr>
+        <p:txBody>
+          <a:bodyPr/>
+          <a:p/>
+        </p:txBody>
       </p:sp>
       <p:sp>
         <p:nvSpPr>
@@ -30931,6 +31623,10 @@
             <a:prstDash val="solid"/>
           </a:ln>
         </p:spPr>
+        <p:txBody>
+          <a:bodyPr/>
+          <a:p/>
+        </p:txBody>
       </p:sp>
       <p:sp>
         <p:nvSpPr>
@@ -30956,6 +31652,10 @@
             <a:prstDash val="solid"/>
           </a:ln>
         </p:spPr>
+        <p:txBody>
+          <a:bodyPr/>
+          <a:p/>
+        </p:txBody>
       </p:sp>
       <p:sp>
         <p:nvSpPr>
@@ -31093,6 +31793,10 @@
             <a:prstDash val="solid"/>
           </a:ln>
         </p:spPr>
+        <p:txBody>
+          <a:bodyPr/>
+          <a:p/>
+        </p:txBody>
       </p:sp>
       <p:sp>
         <p:nvSpPr>
@@ -31118,6 +31822,10 @@
             <a:prstDash val="solid"/>
           </a:ln>
         </p:spPr>
+        <p:txBody>
+          <a:bodyPr/>
+          <a:p/>
+        </p:txBody>
       </p:sp>
       <p:sp>
         <p:nvSpPr>
@@ -31255,6 +31963,10 @@
             <a:prstDash val="solid"/>
           </a:ln>
         </p:spPr>
+        <p:txBody>
+          <a:bodyPr/>
+          <a:p/>
+        </p:txBody>
       </p:sp>
       <p:sp>
         <p:nvSpPr>
@@ -31390,6 +32102,10 @@
             <a:prstDash val="solid"/>
           </a:ln>
         </p:spPr>
+        <p:txBody>
+          <a:bodyPr/>
+          <a:p/>
+        </p:txBody>
       </p:sp>
       <p:sp>
         <p:nvSpPr>
@@ -31415,6 +32131,10 @@
             <a:prstDash val="solid"/>
           </a:ln>
         </p:spPr>
+        <p:txBody>
+          <a:bodyPr/>
+          <a:p/>
+        </p:txBody>
       </p:sp>
       <p:sp>
         <p:nvSpPr>
@@ -31557,6 +32277,10 @@
             <a:prstDash val="solid"/>
           </a:ln>
         </p:spPr>
+        <p:txBody>
+          <a:bodyPr/>
+          <a:p/>
+        </p:txBody>
       </p:sp>
       <p:sp>
         <p:nvSpPr>
@@ -31685,6 +32409,10 @@
             <a:prstDash val="solid"/>
           </a:ln>
         </p:spPr>
+        <p:txBody>
+          <a:bodyPr/>
+          <a:p/>
+        </p:txBody>
       </p:sp>
       <p:sp>
         <p:nvSpPr>
@@ -31710,6 +32438,10 @@
             <a:prstDash val="solid"/>
           </a:ln>
         </p:spPr>
+        <p:txBody>
+          <a:bodyPr/>
+          <a:p/>
+        </p:txBody>
       </p:sp>
       <p:sp>
         <p:nvSpPr>
@@ -33487,6 +34219,10 @@
             <a:prstDash val="solid"/>
           </a:ln>
         </p:spPr>
+        <p:txBody>
+          <a:bodyPr/>
+          <a:p/>
+        </p:txBody>
       </p:sp>
       <p:sp>
         <p:nvSpPr>
@@ -33615,6 +34351,10 @@
             <a:prstDash val="solid"/>
           </a:ln>
         </p:spPr>
+        <p:txBody>
+          <a:bodyPr/>
+          <a:p/>
+        </p:txBody>
       </p:sp>
       <p:sp>
         <p:nvSpPr>
@@ -33640,6 +34380,10 @@
             <a:prstDash val="solid"/>
           </a:ln>
         </p:spPr>
+        <p:txBody>
+          <a:bodyPr/>
+          <a:p/>
+        </p:txBody>
       </p:sp>
       <p:sp>
         <p:nvSpPr>
@@ -36293,6 +37037,10 @@
             <a:prstDash val="solid"/>
           </a:ln>
         </p:spPr>
+        <p:txBody>
+          <a:bodyPr/>
+          <a:p/>
+        </p:txBody>
       </p:sp>
       <p:sp>
         <p:nvSpPr>
@@ -36421,6 +37169,10 @@
             <a:prstDash val="solid"/>
           </a:ln>
         </p:spPr>
+        <p:txBody>
+          <a:bodyPr/>
+          <a:p/>
+        </p:txBody>
       </p:sp>
       <p:sp>
         <p:nvSpPr>
@@ -36446,6 +37198,10 @@
             <a:prstDash val="solid"/>
           </a:ln>
         </p:spPr>
+        <p:txBody>
+          <a:bodyPr/>
+          <a:p/>
+        </p:txBody>
       </p:sp>
       <p:sp>
         <p:nvSpPr>
@@ -37342,7 +38098,7 @@
                           <a:ea typeface="Calibri" pitchFamily="34" charset="-122"/>
                           <a:cs typeface="Calibri" pitchFamily="34" charset="-120"/>
                         </a:rPr>
-                        <a:t>Lovable Developer</a:t>
+                        <a:t>Platform Developer</a:t>
                       </a:r>
                       <a:endParaRPr lang="en-US" sz="1300" dirty="0">
                         <a:latin typeface="Calibri" charset="0"/>
@@ -37888,6 +38644,10 @@
             <a:prstDash val="solid"/>
           </a:ln>
         </p:spPr>
+        <p:txBody>
+          <a:bodyPr/>
+          <a:p/>
+        </p:txBody>
       </p:sp>
       <p:sp>
         <p:nvSpPr>
@@ -38016,6 +38776,10 @@
             <a:prstDash val="solid"/>
           </a:ln>
         </p:spPr>
+        <p:txBody>
+          <a:bodyPr/>
+          <a:p/>
+        </p:txBody>
       </p:sp>
       <p:sp>
         <p:nvSpPr>
@@ -38041,6 +38805,10 @@
             <a:prstDash val="solid"/>
           </a:ln>
         </p:spPr>
+        <p:txBody>
+          <a:bodyPr/>
+          <a:p/>
+        </p:txBody>
       </p:sp>
       <p:sp>
         <p:nvSpPr>
@@ -39178,6 +39946,348 @@
                           <a:ea typeface="Calibri" pitchFamily="34" charset="-122"/>
                           <a:cs typeface="Calibri" pitchFamily="34" charset="-120"/>
                         </a:rPr>
+                        <a:t>Tenant Admin</a:t>
+                      </a:r>
+                      <a:endParaRPr lang="en-US" sz="1300" dirty="0">
+                        <a:latin typeface="Calibri" charset="0"/>
+                        <a:ea typeface="Calibri" charset="0"/>
+                        <a:cs typeface="Calibri" charset="0"/>
+                      </a:endParaRPr>
+                    </a:p>
+                  </a:txBody>
+                  <a:tcPr marL="91440" marR="91440" marT="45720" marB="45720" anchor="ctr">
+                    <a:lnL w="6350" cap="flat" cmpd="sng" algn="ctr">
+                      <a:solidFill>
+                        <a:srgbClr val="CCCCCC"/>
+                      </a:solidFill>
+                      <a:prstDash val="solid"/>
+                      <a:round/>
+                      <a:headEnd type="none" w="med" len="med"/>
+                      <a:tailEnd type="none" w="med" len="med"/>
+                    </a:lnL>
+                    <a:lnR w="6350" cap="flat" cmpd="sng" algn="ctr">
+                      <a:solidFill>
+                        <a:srgbClr val="CCCCCC"/>
+                      </a:solidFill>
+                      <a:prstDash val="solid"/>
+                      <a:round/>
+                      <a:headEnd type="none" w="med" len="med"/>
+                      <a:tailEnd type="none" w="med" len="med"/>
+                    </a:lnR>
+                    <a:lnT w="6350" cap="flat" cmpd="sng" algn="ctr">
+                      <a:solidFill>
+                        <a:srgbClr val="CCCCCC"/>
+                      </a:solidFill>
+                      <a:prstDash val="solid"/>
+                      <a:round/>
+                      <a:headEnd type="none" w="med" len="med"/>
+                      <a:tailEnd type="none" w="med" len="med"/>
+                    </a:lnT>
+                    <a:lnB w="6350" cap="flat" cmpd="sng" algn="ctr">
+                      <a:solidFill>
+                        <a:srgbClr val="CCCCCC"/>
+                      </a:solidFill>
+                      <a:prstDash val="solid"/>
+                      <a:round/>
+                      <a:headEnd type="none" w="med" len="med"/>
+                      <a:tailEnd type="none" w="med" len="med"/>
+                    </a:lnB>
+                    <a:solidFill>
+                      <a:srgbClr val="F2F4FA"/>
+                    </a:solidFill>
+                  </a:tcPr>
+                </a:tc>
+                <a:tc>
+                  <a:txBody>
+                    <a:bodyPr/>
+                    <a:lstStyle/>
+                    <a:p>
+                      <a:pPr indent="0" marL="0">
+                        <a:buNone/>
+                      </a:pPr>
+                      <a:r>
+                        <a:rPr lang="en-US" sz="1300" dirty="0">
+                          <a:solidFill>
+                            <a:srgbClr val="1E1E3A"/>
+                          </a:solidFill>
+                          <a:latin typeface="Calibri" pitchFamily="34" charset="0"/>
+                          <a:ea typeface="Calibri" pitchFamily="34" charset="-122"/>
+                          <a:cs typeface="Calibri" pitchFamily="34" charset="-120"/>
+                        </a:rPr>
+                        <a:t>tenant.admin@boost.test</a:t>
+                      </a:r>
+                      <a:endParaRPr lang="en-US" sz="1300" dirty="0">
+                        <a:latin typeface="Calibri" charset="0"/>
+                        <a:ea typeface="Calibri" charset="0"/>
+                        <a:cs typeface="Calibri" charset="0"/>
+                      </a:endParaRPr>
+                    </a:p>
+                  </a:txBody>
+                  <a:tcPr marL="91440" marR="91440" marT="45720" marB="45720" anchor="ctr">
+                    <a:lnL w="6350" cap="flat" cmpd="sng" algn="ctr">
+                      <a:solidFill>
+                        <a:srgbClr val="CCCCCC"/>
+                      </a:solidFill>
+                      <a:prstDash val="solid"/>
+                      <a:round/>
+                      <a:headEnd type="none" w="med" len="med"/>
+                      <a:tailEnd type="none" w="med" len="med"/>
+                    </a:lnL>
+                    <a:lnR w="6350" cap="flat" cmpd="sng" algn="ctr">
+                      <a:solidFill>
+                        <a:srgbClr val="CCCCCC"/>
+                      </a:solidFill>
+                      <a:prstDash val="solid"/>
+                      <a:round/>
+                      <a:headEnd type="none" w="med" len="med"/>
+                      <a:tailEnd type="none" w="med" len="med"/>
+                    </a:lnR>
+                    <a:lnT w="6350" cap="flat" cmpd="sng" algn="ctr">
+                      <a:solidFill>
+                        <a:srgbClr val="CCCCCC"/>
+                      </a:solidFill>
+                      <a:prstDash val="solid"/>
+                      <a:round/>
+                      <a:headEnd type="none" w="med" len="med"/>
+                      <a:tailEnd type="none" w="med" len="med"/>
+                    </a:lnT>
+                    <a:lnB w="6350" cap="flat" cmpd="sng" algn="ctr">
+                      <a:solidFill>
+                        <a:srgbClr val="CCCCCC"/>
+                      </a:solidFill>
+                      <a:prstDash val="solid"/>
+                      <a:round/>
+                      <a:headEnd type="none" w="med" len="med"/>
+                      <a:tailEnd type="none" w="med" len="med"/>
+                    </a:lnB>
+                    <a:solidFill>
+                      <a:srgbClr val="F2F4FA"/>
+                    </a:solidFill>
+                  </a:tcPr>
+                </a:tc>
+                <a:tc>
+                  <a:txBody>
+                    <a:bodyPr/>
+                    <a:lstStyle/>
+                    <a:p>
+                      <a:pPr indent="0" marL="0">
+                        <a:buNone/>
+                      </a:pPr>
+                      <a:r>
+                        <a:rPr lang="en-US" sz="1300" dirty="0">
+                          <a:solidFill>
+                            <a:srgbClr val="1E1E3A"/>
+                          </a:solidFill>
+                          <a:latin typeface="Calibri" pitchFamily="34" charset="0"/>
+                          <a:ea typeface="Calibri" pitchFamily="34" charset="-122"/>
+                          <a:cs typeface="Calibri" pitchFamily="34" charset="-120"/>
+                        </a:rPr>
+                        <a:t>tenant_admin</a:t>
+                      </a:r>
+                      <a:endParaRPr lang="en-US" sz="1300" dirty="0">
+                        <a:latin typeface="Calibri" charset="0"/>
+                        <a:ea typeface="Calibri" charset="0"/>
+                        <a:cs typeface="Calibri" charset="0"/>
+                      </a:endParaRPr>
+                    </a:p>
+                  </a:txBody>
+                  <a:tcPr marL="91440" marR="91440" marT="45720" marB="45720" anchor="ctr">
+                    <a:lnL w="6350" cap="flat" cmpd="sng" algn="ctr">
+                      <a:solidFill>
+                        <a:srgbClr val="CCCCCC"/>
+                      </a:solidFill>
+                      <a:prstDash val="solid"/>
+                      <a:round/>
+                      <a:headEnd type="none" w="med" len="med"/>
+                      <a:tailEnd type="none" w="med" len="med"/>
+                    </a:lnL>
+                    <a:lnR w="6350" cap="flat" cmpd="sng" algn="ctr">
+                      <a:solidFill>
+                        <a:srgbClr val="CCCCCC"/>
+                      </a:solidFill>
+                      <a:prstDash val="solid"/>
+                      <a:round/>
+                      <a:headEnd type="none" w="med" len="med"/>
+                      <a:tailEnd type="none" w="med" len="med"/>
+                    </a:lnR>
+                    <a:lnT w="6350" cap="flat" cmpd="sng" algn="ctr">
+                      <a:solidFill>
+                        <a:srgbClr val="CCCCCC"/>
+                      </a:solidFill>
+                      <a:prstDash val="solid"/>
+                      <a:round/>
+                      <a:headEnd type="none" w="med" len="med"/>
+                      <a:tailEnd type="none" w="med" len="med"/>
+                    </a:lnT>
+                    <a:lnB w="6350" cap="flat" cmpd="sng" algn="ctr">
+                      <a:solidFill>
+                        <a:srgbClr val="CCCCCC"/>
+                      </a:solidFill>
+                      <a:prstDash val="solid"/>
+                      <a:round/>
+                      <a:headEnd type="none" w="med" len="med"/>
+                      <a:tailEnd type="none" w="med" len="med"/>
+                    </a:lnB>
+                    <a:solidFill>
+                      <a:srgbClr val="F2F4FA"/>
+                    </a:solidFill>
+                  </a:tcPr>
+                </a:tc>
+                <a:tc>
+                  <a:txBody>
+                    <a:bodyPr/>
+                    <a:lstStyle/>
+                    <a:p>
+                      <a:pPr indent="0" marL="0">
+                        <a:buNone/>
+                      </a:pPr>
+                      <a:r>
+                        <a:rPr lang="en-US" sz="1300" dirty="0">
+                          <a:solidFill>
+                            <a:srgbClr val="1E1E3A"/>
+                          </a:solidFill>
+                          <a:latin typeface="Calibri" pitchFamily="34" charset="0"/>
+                          <a:ea typeface="Calibri" pitchFamily="34" charset="-122"/>
+                          <a:cs typeface="Calibri" pitchFamily="34" charset="-120"/>
+                        </a:rPr>
+                        <a:t>CCCOEO (demo)</a:t>
+                      </a:r>
+                      <a:endParaRPr lang="en-US" sz="1300" dirty="0">
+                        <a:latin typeface="Calibri" charset="0"/>
+                        <a:ea typeface="Calibri" charset="0"/>
+                        <a:cs typeface="Calibri" charset="0"/>
+                      </a:endParaRPr>
+                    </a:p>
+                  </a:txBody>
+                  <a:tcPr marL="91440" marR="91440" marT="45720" marB="45720" anchor="ctr">
+                    <a:lnL w="6350" cap="flat" cmpd="sng" algn="ctr">
+                      <a:solidFill>
+                        <a:srgbClr val="CCCCCC"/>
+                      </a:solidFill>
+                      <a:prstDash val="solid"/>
+                      <a:round/>
+                      <a:headEnd type="none" w="med" len="med"/>
+                      <a:tailEnd type="none" w="med" len="med"/>
+                    </a:lnL>
+                    <a:lnR w="6350" cap="flat" cmpd="sng" algn="ctr">
+                      <a:solidFill>
+                        <a:srgbClr val="CCCCCC"/>
+                      </a:solidFill>
+                      <a:prstDash val="solid"/>
+                      <a:round/>
+                      <a:headEnd type="none" w="med" len="med"/>
+                      <a:tailEnd type="none" w="med" len="med"/>
+                    </a:lnR>
+                    <a:lnT w="6350" cap="flat" cmpd="sng" algn="ctr">
+                      <a:solidFill>
+                        <a:srgbClr val="CCCCCC"/>
+                      </a:solidFill>
+                      <a:prstDash val="solid"/>
+                      <a:round/>
+                      <a:headEnd type="none" w="med" len="med"/>
+                      <a:tailEnd type="none" w="med" len="med"/>
+                    </a:lnT>
+                    <a:lnB w="6350" cap="flat" cmpd="sng" algn="ctr">
+                      <a:solidFill>
+                        <a:srgbClr val="CCCCCC"/>
+                      </a:solidFill>
+                      <a:prstDash val="solid"/>
+                      <a:round/>
+                      <a:headEnd type="none" w="med" len="med"/>
+                      <a:tailEnd type="none" w="med" len="med"/>
+                    </a:lnB>
+                    <a:solidFill>
+                      <a:srgbClr val="F2F4FA"/>
+                    </a:solidFill>
+                  </a:tcPr>
+                </a:tc>
+                <a:tc>
+                  <a:txBody>
+                    <a:bodyPr/>
+                    <a:lstStyle/>
+                    <a:p>
+                      <a:pPr indent="0" marL="0">
+                        <a:buNone/>
+                      </a:pPr>
+                      <a:r>
+                        <a:rPr lang="en-US" sz="1300" dirty="0">
+                          <a:solidFill>
+                            <a:srgbClr val="1E1E3A"/>
+                          </a:solidFill>
+                          <a:latin typeface="Calibri" pitchFamily="34" charset="0"/>
+                          <a:ea typeface="Calibri" pitchFamily="34" charset="-122"/>
+                          <a:cs typeface="Calibri" pitchFamily="34" charset="-120"/>
+                        </a:rPr>
+                        <a:t>Client admin panel — module config, employee management, reporting</a:t>
+                      </a:r>
+                      <a:endParaRPr lang="en-US" sz="1300" dirty="0">
+                        <a:latin typeface="Calibri" charset="0"/>
+                        <a:ea typeface="Calibri" charset="0"/>
+                        <a:cs typeface="Calibri" charset="0"/>
+                      </a:endParaRPr>
+                    </a:p>
+                  </a:txBody>
+                  <a:tcPr marL="91440" marR="91440" marT="45720" marB="45720" anchor="ctr">
+                    <a:lnL w="6350" cap="flat" cmpd="sng" algn="ctr">
+                      <a:solidFill>
+                        <a:srgbClr val="CCCCCC"/>
+                      </a:solidFill>
+                      <a:prstDash val="solid"/>
+                      <a:round/>
+                      <a:headEnd type="none" w="med" len="med"/>
+                      <a:tailEnd type="none" w="med" len="med"/>
+                    </a:lnL>
+                    <a:lnR w="6350" cap="flat" cmpd="sng" algn="ctr">
+                      <a:solidFill>
+                        <a:srgbClr val="CCCCCC"/>
+                      </a:solidFill>
+                      <a:prstDash val="solid"/>
+                      <a:round/>
+                      <a:headEnd type="none" w="med" len="med"/>
+                      <a:tailEnd type="none" w="med" len="med"/>
+                    </a:lnR>
+                    <a:lnT w="6350" cap="flat" cmpd="sng" algn="ctr">
+                      <a:solidFill>
+                        <a:srgbClr val="CCCCCC"/>
+                      </a:solidFill>
+                      <a:prstDash val="solid"/>
+                      <a:round/>
+                      <a:headEnd type="none" w="med" len="med"/>
+                      <a:tailEnd type="none" w="med" len="med"/>
+                    </a:lnT>
+                    <a:lnB w="6350" cap="flat" cmpd="sng" algn="ctr">
+                      <a:solidFill>
+                        <a:srgbClr val="CCCCCC"/>
+                      </a:solidFill>
+                      <a:prstDash val="solid"/>
+                      <a:round/>
+                      <a:headEnd type="none" w="med" len="med"/>
+                      <a:tailEnd type="none" w="med" len="med"/>
+                    </a:lnB>
+                    <a:solidFill>
+                      <a:srgbClr val="F2F4FA"/>
+                    </a:solidFill>
+                  </a:tcPr>
+                </a:tc>
+              </a:tr>
+              <a:tr h="640080">
+                <a:tc>
+                  <a:txBody>
+                    <a:bodyPr/>
+                    <a:lstStyle/>
+                    <a:p>
+                      <a:pPr indent="0" marL="0">
+                        <a:buNone/>
+                      </a:pPr>
+                      <a:r>
+                        <a:rPr lang="en-US" sz="1300" dirty="0">
+                          <a:solidFill>
+                            <a:srgbClr val="1E1E3A"/>
+                          </a:solidFill>
+                          <a:latin typeface="Calibri" pitchFamily="34" charset="0"/>
+                          <a:ea typeface="Calibri" pitchFamily="34" charset="-122"/>
+                          <a:cs typeface="Calibri" pitchFamily="34" charset="-120"/>
+                        </a:rPr>
                         <a:t>Learner</a:t>
                       </a:r>
                       <a:endParaRPr lang="en-US" sz="1300" dirty="0">
@@ -39515,6 +40625,10 @@
             <a:prstDash val="solid"/>
           </a:ln>
         </p:spPr>
+        <p:txBody>
+          <a:bodyPr/>
+          <a:p/>
+        </p:txBody>
       </p:sp>
       <p:sp>
         <p:nvSpPr>
@@ -39579,6 +40693,10 @@
             <a:prstDash val="solid"/>
           </a:ln>
         </p:spPr>
+        <p:txBody>
+          <a:bodyPr/>
+          <a:p/>
+        </p:txBody>
       </p:sp>
       <p:sp>
         <p:nvSpPr>
@@ -39714,6 +40832,10 @@
             <a:prstDash val="solid"/>
           </a:ln>
         </p:spPr>
+        <p:txBody>
+          <a:bodyPr/>
+          <a:p/>
+        </p:txBody>
       </p:sp>
       <p:sp>
         <p:nvSpPr>
@@ -39978,6 +41100,10 @@
             <a:prstDash val="solid"/>
           </a:ln>
         </p:spPr>
+        <p:txBody>
+          <a:bodyPr/>
+          <a:p/>
+        </p:txBody>
       </p:sp>
       <p:sp>
         <p:nvSpPr>
@@ -40067,6 +41193,10 @@
             <a:prstDash val="solid"/>
           </a:ln>
         </p:spPr>
+        <p:txBody>
+          <a:bodyPr/>
+          <a:p/>
+        </p:txBody>
       </p:sp>
       <p:sp>
         <p:nvSpPr>
@@ -40092,6 +41222,10 @@
             <a:prstDash val="solid"/>
           </a:ln>
         </p:spPr>
+        <p:txBody>
+          <a:bodyPr/>
+          <a:p/>
+        </p:txBody>
       </p:sp>
       <p:sp>
         <p:nvSpPr>
@@ -40273,6 +41407,10 @@
             <a:prstDash val="solid"/>
           </a:ln>
         </p:spPr>
+        <p:txBody>
+          <a:bodyPr/>
+          <a:p/>
+        </p:txBody>
       </p:sp>
       <p:sp>
         <p:nvSpPr>
@@ -40298,6 +41436,10 @@
             <a:prstDash val="solid"/>
           </a:ln>
         </p:spPr>
+        <p:txBody>
+          <a:bodyPr/>
+          <a:p/>
+        </p:txBody>
       </p:sp>
       <p:sp>
         <p:nvSpPr>
@@ -40418,6 +41560,10 @@
             <a:prstDash val="solid"/>
           </a:ln>
         </p:spPr>
+        <p:txBody>
+          <a:bodyPr/>
+          <a:p/>
+        </p:txBody>
       </p:sp>
       <p:sp>
         <p:nvSpPr>
@@ -40443,6 +41589,10 @@
             <a:prstDash val="solid"/>
           </a:ln>
         </p:spPr>
+        <p:txBody>
+          <a:bodyPr/>
+          <a:p/>
+        </p:txBody>
       </p:sp>
       <p:sp>
         <p:nvSpPr>
@@ -40580,6 +41730,10 @@
             <a:prstDash val="solid"/>
           </a:ln>
         </p:spPr>
+        <p:txBody>
+          <a:bodyPr/>
+          <a:p/>
+        </p:txBody>
       </p:sp>
       <p:sp>
         <p:nvSpPr>
@@ -40605,6 +41759,10 @@
             <a:prstDash val="solid"/>
           </a:ln>
         </p:spPr>
+        <p:txBody>
+          <a:bodyPr/>
+          <a:p/>
+        </p:txBody>
       </p:sp>
       <p:sp>
         <p:nvSpPr>
@@ -40742,6 +41900,10 @@
             <a:prstDash val="solid"/>
           </a:ln>
         </p:spPr>
+        <p:txBody>
+          <a:bodyPr/>
+          <a:p/>
+        </p:txBody>
       </p:sp>
       <p:sp>
         <p:nvSpPr>
@@ -40806,6 +41968,10 @@
             <a:prstDash val="solid"/>
           </a:ln>
         </p:spPr>
+        <p:txBody>
+          <a:bodyPr/>
+          <a:p/>
+        </p:txBody>
       </p:sp>
       <p:sp>
         <p:nvSpPr>
@@ -40934,6 +42100,10 @@
             <a:prstDash val="solid"/>
           </a:ln>
         </p:spPr>
+        <p:txBody>
+          <a:bodyPr/>
+          <a:p/>
+        </p:txBody>
       </p:sp>
       <p:sp>
         <p:nvSpPr>
@@ -40959,6 +42129,10 @@
             <a:prstDash val="solid"/>
           </a:ln>
         </p:spPr>
+        <p:txBody>
+          <a:bodyPr/>
+          <a:p/>
+        </p:txBody>
       </p:sp>
       <p:sp>
         <p:nvSpPr>
@@ -41023,6 +42197,10 @@
             <a:prstDash val="solid"/>
           </a:ln>
         </p:spPr>
+        <p:txBody>
+          <a:bodyPr/>
+          <a:p/>
+        </p:txBody>
       </p:sp>
       <p:sp>
         <p:nvSpPr>
@@ -41048,6 +42226,10 @@
             <a:prstDash val="solid"/>
           </a:ln>
         </p:spPr>
+        <p:txBody>
+          <a:bodyPr/>
+          <a:p/>
+        </p:txBody>
       </p:sp>
       <p:sp>
         <p:nvSpPr>
@@ -41260,6 +42442,10 @@
             <a:prstDash val="solid"/>
           </a:ln>
         </p:spPr>
+        <p:txBody>
+          <a:bodyPr/>
+          <a:p/>
+        </p:txBody>
       </p:sp>
       <p:sp>
         <p:nvSpPr>
@@ -41285,6 +42471,10 @@
             <a:prstDash val="solid"/>
           </a:ln>
         </p:spPr>
+        <p:txBody>
+          <a:bodyPr/>
+          <a:p/>
+        </p:txBody>
       </p:sp>
       <p:sp>
         <p:nvSpPr>
@@ -41497,6 +42687,10 @@
             <a:prstDash val="solid"/>
           </a:ln>
         </p:spPr>
+        <p:txBody>
+          <a:bodyPr/>
+          <a:p/>
+        </p:txBody>
       </p:sp>
       <p:sp>
         <p:nvSpPr>
@@ -41522,6 +42716,10 @@
             <a:prstDash val="solid"/>
           </a:ln>
         </p:spPr>
+        <p:txBody>
+          <a:bodyPr/>
+          <a:p/>
+        </p:txBody>
       </p:sp>
       <p:sp>
         <p:nvSpPr>
@@ -41734,6 +42932,10 @@
             <a:prstDash val="solid"/>
           </a:ln>
         </p:spPr>
+        <p:txBody>
+          <a:bodyPr/>
+          <a:p/>
+        </p:txBody>
       </p:sp>
       <p:sp>
         <p:nvSpPr>
@@ -41869,6 +43071,10 @@
             <a:prstDash val="solid"/>
           </a:ln>
         </p:spPr>
+        <p:txBody>
+          <a:bodyPr/>
+          <a:p/>
+        </p:txBody>
       </p:sp>
       <p:sp>
         <p:nvSpPr>
@@ -41894,6 +43100,10 @@
             <a:prstDash val="solid"/>
           </a:ln>
         </p:spPr>
+        <p:txBody>
+          <a:bodyPr/>
+          <a:p/>
+        </p:txBody>
       </p:sp>
       <p:sp>
         <p:nvSpPr>
@@ -42036,6 +43246,10 @@
             <a:prstDash val="solid"/>
           </a:ln>
         </p:spPr>
+        <p:txBody>
+          <a:bodyPr/>
+          <a:p/>
+        </p:txBody>
       </p:sp>
       <p:sp>
         <p:nvSpPr>
@@ -42164,6 +43378,10 @@
             <a:prstDash val="solid"/>
           </a:ln>
         </p:spPr>
+        <p:txBody>
+          <a:bodyPr/>
+          <a:p/>
+        </p:txBody>
       </p:sp>
       <p:sp>
         <p:nvSpPr>
@@ -42189,6 +43407,10 @@
             <a:prstDash val="solid"/>
           </a:ln>
         </p:spPr>
+        <p:txBody>
+          <a:bodyPr/>
+          <a:p/>
+        </p:txBody>
       </p:sp>
       <p:sp>
         <p:nvSpPr>
@@ -42861,6 +44083,203 @@
                           <a:ea typeface="Calibri" pitchFamily="34" charset="-122"/>
                           <a:cs typeface="Calibri" pitchFamily="34" charset="-120"/>
                         </a:rPr>
+                        <a:t>Tenant Admin (client view)</a:t>
+                      </a:r>
+                      <a:endParaRPr lang="en-US" sz="1300" dirty="0">
+                        <a:latin typeface="Calibri" charset="0"/>
+                        <a:ea typeface="Calibri" charset="0"/>
+                        <a:cs typeface="Calibri" charset="0"/>
+                      </a:endParaRPr>
+                    </a:p>
+                  </a:txBody>
+                  <a:tcPr marL="91440" marR="91440" marT="45720" marB="45720" anchor="ctr">
+                    <a:lnL w="6350" cap="flat" cmpd="sng" algn="ctr">
+                      <a:solidFill>
+                        <a:srgbClr val="CCCCCC"/>
+                      </a:solidFill>
+                      <a:prstDash val="solid"/>
+                      <a:round/>
+                      <a:headEnd type="none" w="med" len="med"/>
+                      <a:tailEnd type="none" w="med" len="med"/>
+                    </a:lnL>
+                    <a:lnR w="6350" cap="flat" cmpd="sng" algn="ctr">
+                      <a:solidFill>
+                        <a:srgbClr val="CCCCCC"/>
+                      </a:solidFill>
+                      <a:prstDash val="solid"/>
+                      <a:round/>
+                      <a:headEnd type="none" w="med" len="med"/>
+                      <a:tailEnd type="none" w="med" len="med"/>
+                    </a:lnR>
+                    <a:lnT w="6350" cap="flat" cmpd="sng" algn="ctr">
+                      <a:solidFill>
+                        <a:srgbClr val="CCCCCC"/>
+                      </a:solidFill>
+                      <a:prstDash val="solid"/>
+                      <a:round/>
+                      <a:headEnd type="none" w="med" len="med"/>
+                      <a:tailEnd type="none" w="med" len="med"/>
+                    </a:lnT>
+                    <a:lnB w="6350" cap="flat" cmpd="sng" algn="ctr">
+                      <a:solidFill>
+                        <a:srgbClr val="CCCCCC"/>
+                      </a:solidFill>
+                      <a:prstDash val="solid"/>
+                      <a:round/>
+                      <a:headEnd type="none" w="med" len="med"/>
+                      <a:tailEnd type="none" w="med" len="med"/>
+                    </a:lnB>
+                  </a:tcPr>
+                </a:tc>
+                <a:tc>
+                  <a:txBody>
+                    <a:bodyPr/>
+                    <a:lstStyle/>
+                    <a:p>
+                      <a:pPr indent="0" marL="0">
+                        <a:buNone/>
+                      </a:pPr>
+                      <a:r>
+                        <a:rPr lang="en-US" sz="1300" dirty="0">
+                          <a:solidFill>
+                            <a:srgbClr val="1E1E3A"/>
+                          </a:solidFill>
+                          <a:latin typeface="Calibri" pitchFamily="34" charset="0"/>
+                          <a:ea typeface="Calibri" pitchFamily="34" charset="-122"/>
+                          <a:cs typeface="Calibri" pitchFamily="34" charset="-120"/>
+                        </a:rPr>
+                        <a:t>tenant.admin@boost.test</a:t>
+                      </a:r>
+                      <a:endParaRPr lang="en-US" sz="1300" dirty="0">
+                        <a:latin typeface="Calibri" charset="0"/>
+                        <a:ea typeface="Calibri" charset="0"/>
+                        <a:cs typeface="Calibri" charset="0"/>
+                      </a:endParaRPr>
+                    </a:p>
+                  </a:txBody>
+                  <a:tcPr marL="91440" marR="91440" marT="45720" marB="45720" anchor="ctr">
+                    <a:lnL w="6350" cap="flat" cmpd="sng" algn="ctr">
+                      <a:solidFill>
+                        <a:srgbClr val="CCCCCC"/>
+                      </a:solidFill>
+                      <a:prstDash val="solid"/>
+                      <a:round/>
+                      <a:headEnd type="none" w="med" len="med"/>
+                      <a:tailEnd type="none" w="med" len="med"/>
+                    </a:lnL>
+                    <a:lnR w="6350" cap="flat" cmpd="sng" algn="ctr">
+                      <a:solidFill>
+                        <a:srgbClr val="CCCCCC"/>
+                      </a:solidFill>
+                      <a:prstDash val="solid"/>
+                      <a:round/>
+                      <a:headEnd type="none" w="med" len="med"/>
+                      <a:tailEnd type="none" w="med" len="med"/>
+                    </a:lnR>
+                    <a:lnT w="6350" cap="flat" cmpd="sng" algn="ctr">
+                      <a:solidFill>
+                        <a:srgbClr val="CCCCCC"/>
+                      </a:solidFill>
+                      <a:prstDash val="solid"/>
+                      <a:round/>
+                      <a:headEnd type="none" w="med" len="med"/>
+                      <a:tailEnd type="none" w="med" len="med"/>
+                    </a:lnT>
+                    <a:lnB w="6350" cap="flat" cmpd="sng" algn="ctr">
+                      <a:solidFill>
+                        <a:srgbClr val="CCCCCC"/>
+                      </a:solidFill>
+                      <a:prstDash val="solid"/>
+                      <a:round/>
+                      <a:headEnd type="none" w="med" len="med"/>
+                      <a:tailEnd type="none" w="med" len="med"/>
+                    </a:lnB>
+                  </a:tcPr>
+                </a:tc>
+                <a:tc>
+                  <a:txBody>
+                    <a:bodyPr/>
+                    <a:lstStyle/>
+                    <a:p>
+                      <a:pPr indent="0" marL="0">
+                        <a:buNone/>
+                      </a:pPr>
+                      <a:r>
+                        <a:rPr lang="en-US" sz="1300" dirty="0">
+                          <a:solidFill>
+                            <a:srgbClr val="1E1E3A"/>
+                          </a:solidFill>
+                          <a:latin typeface="Calibri" pitchFamily="34" charset="0"/>
+                          <a:ea typeface="Calibri" pitchFamily="34" charset="-122"/>
+                          <a:cs typeface="Calibri" pitchFamily="34" charset="-120"/>
+                        </a:rPr>
+                        <a:t>Testing client tenant admin view and experience</a:t>
+                      </a:r>
+                      <a:endParaRPr lang="en-US" sz="1300" dirty="0">
+                        <a:latin typeface="Calibri" charset="0"/>
+                        <a:ea typeface="Calibri" charset="0"/>
+                        <a:cs typeface="Calibri" charset="0"/>
+                      </a:endParaRPr>
+                    </a:p>
+                  </a:txBody>
+                  <a:tcPr marL="91440" marR="91440" marT="45720" marB="45720" anchor="ctr">
+                    <a:lnL w="6350" cap="flat" cmpd="sng" algn="ctr">
+                      <a:solidFill>
+                        <a:srgbClr val="CCCCCC"/>
+                      </a:solidFill>
+                      <a:prstDash val="solid"/>
+                      <a:round/>
+                      <a:headEnd type="none" w="med" len="med"/>
+                      <a:tailEnd type="none" w="med" len="med"/>
+                    </a:lnL>
+                    <a:lnR w="6350" cap="flat" cmpd="sng" algn="ctr">
+                      <a:solidFill>
+                        <a:srgbClr val="CCCCCC"/>
+                      </a:solidFill>
+                      <a:prstDash val="solid"/>
+                      <a:round/>
+                      <a:headEnd type="none" w="med" len="med"/>
+                      <a:tailEnd type="none" w="med" len="med"/>
+                    </a:lnR>
+                    <a:lnT w="6350" cap="flat" cmpd="sng" algn="ctr">
+                      <a:solidFill>
+                        <a:srgbClr val="CCCCCC"/>
+                      </a:solidFill>
+                      <a:prstDash val="solid"/>
+                      <a:round/>
+                      <a:headEnd type="none" w="med" len="med"/>
+                      <a:tailEnd type="none" w="med" len="med"/>
+                    </a:lnT>
+                    <a:lnB w="6350" cap="flat" cmpd="sng" algn="ctr">
+                      <a:solidFill>
+                        <a:srgbClr val="CCCCCC"/>
+                      </a:solidFill>
+                      <a:prstDash val="solid"/>
+                      <a:round/>
+                      <a:headEnd type="none" w="med" len="med"/>
+                      <a:tailEnd type="none" w="med" len="med"/>
+                    </a:lnB>
+                  </a:tcPr>
+                </a:tc>
+              </a:tr>
+              <a:tr h="384048">
+                <a:tc>
+                  <a:txBody>
+                    <a:bodyPr/>
+                    <a:lstStyle/>
+                    <a:p>
+                      <a:pPr indent="0" marL="0">
+                        <a:buNone/>
+                      </a:pPr>
+                      <a:r>
+                        <a:rPr lang="en-US" sz="1300" dirty="0">
+                          <a:solidFill>
+                            <a:srgbClr val="1E1E3A"/>
+                          </a:solidFill>
+                          <a:latin typeface="Calibri" pitchFamily="34" charset="0"/>
+                          <a:ea typeface="Calibri" pitchFamily="34" charset="-122"/>
+                          <a:cs typeface="Calibri" pitchFamily="34" charset="-120"/>
+                        </a:rPr>
                         <a:t>Learner (demo)</a:t>
                       </a:r>
                       <a:endParaRPr lang="en-US" sz="1300" dirty="0">
@@ -43077,6 +44496,10 @@
             <a:prstDash val="solid"/>
           </a:ln>
         </p:spPr>
+        <p:txBody>
+          <a:bodyPr/>
+          <a:p/>
+        </p:txBody>
       </p:sp>
       <p:sp>
         <p:nvSpPr>
@@ -43205,6 +44628,10 @@
             <a:prstDash val="solid"/>
           </a:ln>
         </p:spPr>
+        <p:txBody>
+          <a:bodyPr/>
+          <a:p/>
+        </p:txBody>
       </p:sp>
       <p:sp>
         <p:nvSpPr>
@@ -43230,6 +44657,10 @@
             <a:prstDash val="solid"/>
           </a:ln>
         </p:spPr>
+        <p:txBody>
+          <a:bodyPr/>
+          <a:p/>
+        </p:txBody>
       </p:sp>
       <p:sp>
         <p:nvSpPr>
@@ -43333,6 +44764,10 @@
             <a:prstDash val="solid"/>
           </a:ln>
         </p:spPr>
+        <p:txBody>
+          <a:bodyPr/>
+          <a:p/>
+        </p:txBody>
       </p:sp>
       <p:sp>
         <p:nvSpPr>
@@ -45037,6 +46472,10 @@
             <a:prstDash val="solid"/>
           </a:ln>
         </p:spPr>
+        <p:txBody>
+          <a:bodyPr/>
+          <a:p/>
+        </p:txBody>
       </p:sp>
       <p:sp>
         <p:nvSpPr>
@@ -45101,6 +46540,10 @@
             <a:prstDash val="solid"/>
           </a:ln>
         </p:spPr>
+        <p:txBody>
+          <a:bodyPr/>
+          <a:p/>
+        </p:txBody>
       </p:sp>
       <p:sp>
         <p:nvSpPr>

</xml_diff>